<commit_message>
adding game integration part to powerpoint
</commit_message>
<xml_diff>
--- a/presentation.pptx
+++ b/presentation.pptx
@@ -5,7 +5,7 @@
     <p:sldMasterId id="2147483648" r:id="rId1"/>
   </p:sldMasterIdLst>
   <p:notesMasterIdLst>
-    <p:notesMasterId r:id="rId10"/>
+    <p:notesMasterId r:id="rId12"/>
   </p:notesMasterIdLst>
   <p:sldIdLst>
     <p:sldId id="261" r:id="rId2"/>
@@ -14,8 +14,10 @@
     <p:sldId id="258" r:id="rId5"/>
     <p:sldId id="265" r:id="rId6"/>
     <p:sldId id="267" r:id="rId7"/>
-    <p:sldId id="259" r:id="rId8"/>
-    <p:sldId id="260" r:id="rId9"/>
+    <p:sldId id="270" r:id="rId8"/>
+    <p:sldId id="271" r:id="rId9"/>
+    <p:sldId id="259" r:id="rId10"/>
+    <p:sldId id="260" r:id="rId11"/>
   </p:sldIdLst>
   <p:sldSz cx="12192000" cy="6858000"/>
   <p:notesSz cx="6858000" cy="9144000"/>
@@ -210,7 +212,7 @@
           <a:p>
             <a:fld id="{812DE816-4AEB-4C5E-88A4-F622554AF666}" type="datetimeFigureOut">
               <a:rPr lang="en-GB" smtClean="0"/>
-              <a:t>25/05/2026</a:t>
+              <a:t>26/05/2026</a:t>
             </a:fld>
             <a:endParaRPr lang="en-GB"/>
           </a:p>
@@ -1329,6 +1331,222 @@
 </p:notes>
 </file>
 
+<file path=ppt/notesSlides/notesSlide4.xml><?xml version="1.0" encoding="utf-8"?>
+<p:notes xmlns:a="http://schemas.openxmlformats.org/drawingml/2006/main" xmlns:r="http://schemas.openxmlformats.org/officeDocument/2006/relationships" xmlns:p="http://schemas.openxmlformats.org/presentationml/2006/main">
+  <p:cSld>
+    <p:spTree>
+      <p:nvGrpSpPr>
+        <p:cNvPr id="1" name="">
+          <a:extLst>
+            <a:ext uri="{FF2B5EF4-FFF2-40B4-BE49-F238E27FC236}">
+              <a16:creationId xmlns:a16="http://schemas.microsoft.com/office/drawing/2014/main" id="{014ECA78-4AB8-A85A-AFCD-0818DF9C4EAD}"/>
+            </a:ext>
+          </a:extLst>
+        </p:cNvPr>
+        <p:cNvGrpSpPr/>
+        <p:nvPr/>
+      </p:nvGrpSpPr>
+      <p:grpSpPr>
+        <a:xfrm>
+          <a:off x="0" y="0"/>
+          <a:ext cx="0" cy="0"/>
+          <a:chOff x="0" y="0"/>
+          <a:chExt cx="0" cy="0"/>
+        </a:xfrm>
+      </p:grpSpPr>
+      <p:sp>
+        <p:nvSpPr>
+          <p:cNvPr id="2" name="Slide Image Placeholder 1">
+            <a:extLst>
+              <a:ext uri="{FF2B5EF4-FFF2-40B4-BE49-F238E27FC236}">
+                <a16:creationId xmlns:a16="http://schemas.microsoft.com/office/drawing/2014/main" id="{EFAA382E-819C-7106-3083-9BEE8C4E247C}"/>
+              </a:ext>
+            </a:extLst>
+          </p:cNvPr>
+          <p:cNvSpPr>
+            <a:spLocks noGrp="1" noRot="1" noChangeAspect="1"/>
+          </p:cNvSpPr>
+          <p:nvPr>
+            <p:ph type="sldImg"/>
+          </p:nvPr>
+        </p:nvSpPr>
+        <p:spPr/>
+      </p:sp>
+      <p:sp>
+        <p:nvSpPr>
+          <p:cNvPr id="3" name="Notes Placeholder 2">
+            <a:extLst>
+              <a:ext uri="{FF2B5EF4-FFF2-40B4-BE49-F238E27FC236}">
+                <a16:creationId xmlns:a16="http://schemas.microsoft.com/office/drawing/2014/main" id="{82764A91-D28B-F968-1722-7278EA94902C}"/>
+              </a:ext>
+            </a:extLst>
+          </p:cNvPr>
+          <p:cNvSpPr>
+            <a:spLocks noGrp="1"/>
+          </p:cNvSpPr>
+          <p:nvPr>
+            <p:ph type="body" idx="1"/>
+          </p:nvPr>
+        </p:nvSpPr>
+        <p:spPr/>
+        <p:txBody>
+          <a:bodyPr/>
+          <a:lstStyle/>
+          <a:p>
+            <a:endParaRPr lang="en-GB" dirty="0"/>
+          </a:p>
+        </p:txBody>
+      </p:sp>
+      <p:sp>
+        <p:nvSpPr>
+          <p:cNvPr id="4" name="Slide Number Placeholder 3">
+            <a:extLst>
+              <a:ext uri="{FF2B5EF4-FFF2-40B4-BE49-F238E27FC236}">
+                <a16:creationId xmlns:a16="http://schemas.microsoft.com/office/drawing/2014/main" id="{5B615E4B-577E-AF0F-3A25-102794F6C231}"/>
+              </a:ext>
+            </a:extLst>
+          </p:cNvPr>
+          <p:cNvSpPr>
+            <a:spLocks noGrp="1"/>
+          </p:cNvSpPr>
+          <p:nvPr>
+            <p:ph type="sldNum" sz="quarter" idx="5"/>
+          </p:nvPr>
+        </p:nvSpPr>
+        <p:spPr/>
+        <p:txBody>
+          <a:bodyPr/>
+          <a:lstStyle/>
+          <a:p>
+            <a:fld id="{67FC2F5D-A00A-4392-B28E-0201BF8C74BB}" type="slidenum">
+              <a:rPr lang="en-GB" smtClean="0"/>
+              <a:t>7</a:t>
+            </a:fld>
+            <a:endParaRPr lang="en-GB"/>
+          </a:p>
+        </p:txBody>
+      </p:sp>
+    </p:spTree>
+    <p:extLst>
+      <p:ext uri="{BB962C8B-B14F-4D97-AF65-F5344CB8AC3E}">
+        <p14:creationId xmlns:p14="http://schemas.microsoft.com/office/powerpoint/2010/main" val="3648500059"/>
+      </p:ext>
+    </p:extLst>
+  </p:cSld>
+  <p:clrMapOvr>
+    <a:masterClrMapping/>
+  </p:clrMapOvr>
+</p:notes>
+</file>
+
+<file path=ppt/notesSlides/notesSlide5.xml><?xml version="1.0" encoding="utf-8"?>
+<p:notes xmlns:a="http://schemas.openxmlformats.org/drawingml/2006/main" xmlns:r="http://schemas.openxmlformats.org/officeDocument/2006/relationships" xmlns:p="http://schemas.openxmlformats.org/presentationml/2006/main">
+  <p:cSld>
+    <p:spTree>
+      <p:nvGrpSpPr>
+        <p:cNvPr id="1" name="">
+          <a:extLst>
+            <a:ext uri="{FF2B5EF4-FFF2-40B4-BE49-F238E27FC236}">
+              <a16:creationId xmlns:a16="http://schemas.microsoft.com/office/drawing/2014/main" id="{88100ACA-D4A8-DDB3-2FE0-1C53DF4952E6}"/>
+            </a:ext>
+          </a:extLst>
+        </p:cNvPr>
+        <p:cNvGrpSpPr/>
+        <p:nvPr/>
+      </p:nvGrpSpPr>
+      <p:grpSpPr>
+        <a:xfrm>
+          <a:off x="0" y="0"/>
+          <a:ext cx="0" cy="0"/>
+          <a:chOff x="0" y="0"/>
+          <a:chExt cx="0" cy="0"/>
+        </a:xfrm>
+      </p:grpSpPr>
+      <p:sp>
+        <p:nvSpPr>
+          <p:cNvPr id="2" name="Slide Image Placeholder 1">
+            <a:extLst>
+              <a:ext uri="{FF2B5EF4-FFF2-40B4-BE49-F238E27FC236}">
+                <a16:creationId xmlns:a16="http://schemas.microsoft.com/office/drawing/2014/main" id="{EA861AA4-8115-E8A9-EF6C-D647AE623E40}"/>
+              </a:ext>
+            </a:extLst>
+          </p:cNvPr>
+          <p:cNvSpPr>
+            <a:spLocks noGrp="1" noRot="1" noChangeAspect="1"/>
+          </p:cNvSpPr>
+          <p:nvPr>
+            <p:ph type="sldImg"/>
+          </p:nvPr>
+        </p:nvSpPr>
+        <p:spPr/>
+      </p:sp>
+      <p:sp>
+        <p:nvSpPr>
+          <p:cNvPr id="3" name="Notes Placeholder 2">
+            <a:extLst>
+              <a:ext uri="{FF2B5EF4-FFF2-40B4-BE49-F238E27FC236}">
+                <a16:creationId xmlns:a16="http://schemas.microsoft.com/office/drawing/2014/main" id="{0EF3C81B-F4DC-45A1-DD32-C9BEA16F4C0A}"/>
+              </a:ext>
+            </a:extLst>
+          </p:cNvPr>
+          <p:cNvSpPr>
+            <a:spLocks noGrp="1"/>
+          </p:cNvSpPr>
+          <p:nvPr>
+            <p:ph type="body" idx="1"/>
+          </p:nvPr>
+        </p:nvSpPr>
+        <p:spPr/>
+        <p:txBody>
+          <a:bodyPr/>
+          <a:lstStyle/>
+          <a:p>
+            <a:endParaRPr lang="en-GB" dirty="0"/>
+          </a:p>
+        </p:txBody>
+      </p:sp>
+      <p:sp>
+        <p:nvSpPr>
+          <p:cNvPr id="4" name="Slide Number Placeholder 3">
+            <a:extLst>
+              <a:ext uri="{FF2B5EF4-FFF2-40B4-BE49-F238E27FC236}">
+                <a16:creationId xmlns:a16="http://schemas.microsoft.com/office/drawing/2014/main" id="{A522BE93-F0D7-B8EC-2B2F-CA3A69993ED7}"/>
+              </a:ext>
+            </a:extLst>
+          </p:cNvPr>
+          <p:cNvSpPr>
+            <a:spLocks noGrp="1"/>
+          </p:cNvSpPr>
+          <p:nvPr>
+            <p:ph type="sldNum" sz="quarter" idx="5"/>
+          </p:nvPr>
+        </p:nvSpPr>
+        <p:spPr/>
+        <p:txBody>
+          <a:bodyPr/>
+          <a:lstStyle/>
+          <a:p>
+            <a:fld id="{67FC2F5D-A00A-4392-B28E-0201BF8C74BB}" type="slidenum">
+              <a:rPr lang="en-GB" smtClean="0"/>
+              <a:t>8</a:t>
+            </a:fld>
+            <a:endParaRPr lang="en-GB"/>
+          </a:p>
+        </p:txBody>
+      </p:sp>
+    </p:spTree>
+    <p:extLst>
+      <p:ext uri="{BB962C8B-B14F-4D97-AF65-F5344CB8AC3E}">
+        <p14:creationId xmlns:p14="http://schemas.microsoft.com/office/powerpoint/2010/main" val="704544054"/>
+      </p:ext>
+    </p:extLst>
+  </p:cSld>
+  <p:clrMapOvr>
+    <a:masterClrMapping/>
+  </p:clrMapOvr>
+</p:notes>
+</file>
+
 <file path=ppt/slideLayouts/slideLayout1.xml><?xml version="1.0" encoding="utf-8"?>
 <p:sldLayout xmlns:a="http://schemas.openxmlformats.org/drawingml/2006/main" xmlns:r="http://schemas.openxmlformats.org/officeDocument/2006/relationships" xmlns:p="http://schemas.openxmlformats.org/presentationml/2006/main" type="title" preserve="1">
   <p:cSld name="Titelfolie">
@@ -1476,7 +1694,7 @@
           <a:p>
             <a:fld id="{259F4B15-8AB2-4C86-B5C5-75A9D4FD84E4}" type="datetimeFigureOut">
               <a:rPr lang="de-DE" smtClean="0"/>
-              <a:t>25.05.2026</a:t>
+              <a:t>26.05.2026</a:t>
             </a:fld>
             <a:endParaRPr lang="de-DE"/>
           </a:p>
@@ -1674,7 +1892,7 @@
           <a:p>
             <a:fld id="{259F4B15-8AB2-4C86-B5C5-75A9D4FD84E4}" type="datetimeFigureOut">
               <a:rPr lang="de-DE" smtClean="0"/>
-              <a:t>25.05.2026</a:t>
+              <a:t>26.05.2026</a:t>
             </a:fld>
             <a:endParaRPr lang="de-DE"/>
           </a:p>
@@ -1882,7 +2100,7 @@
           <a:p>
             <a:fld id="{259F4B15-8AB2-4C86-B5C5-75A9D4FD84E4}" type="datetimeFigureOut">
               <a:rPr lang="de-DE" smtClean="0"/>
-              <a:t>25.05.2026</a:t>
+              <a:t>26.05.2026</a:t>
             </a:fld>
             <a:endParaRPr lang="de-DE"/>
           </a:p>
@@ -2080,7 +2298,7 @@
           <a:p>
             <a:fld id="{259F4B15-8AB2-4C86-B5C5-75A9D4FD84E4}" type="datetimeFigureOut">
               <a:rPr lang="de-DE" smtClean="0"/>
-              <a:t>25.05.2026</a:t>
+              <a:t>26.05.2026</a:t>
             </a:fld>
             <a:endParaRPr lang="de-DE"/>
           </a:p>
@@ -2355,7 +2573,7 @@
           <a:p>
             <a:fld id="{259F4B15-8AB2-4C86-B5C5-75A9D4FD84E4}" type="datetimeFigureOut">
               <a:rPr lang="de-DE" smtClean="0"/>
-              <a:t>25.05.2026</a:t>
+              <a:t>26.05.2026</a:t>
             </a:fld>
             <a:endParaRPr lang="de-DE"/>
           </a:p>
@@ -2620,7 +2838,7 @@
           <a:p>
             <a:fld id="{259F4B15-8AB2-4C86-B5C5-75A9D4FD84E4}" type="datetimeFigureOut">
               <a:rPr lang="de-DE" smtClean="0"/>
-              <a:t>25.05.2026</a:t>
+              <a:t>26.05.2026</a:t>
             </a:fld>
             <a:endParaRPr lang="de-DE"/>
           </a:p>
@@ -3032,7 +3250,7 @@
           <a:p>
             <a:fld id="{259F4B15-8AB2-4C86-B5C5-75A9D4FD84E4}" type="datetimeFigureOut">
               <a:rPr lang="de-DE" smtClean="0"/>
-              <a:t>25.05.2026</a:t>
+              <a:t>26.05.2026</a:t>
             </a:fld>
             <a:endParaRPr lang="de-DE"/>
           </a:p>
@@ -3173,7 +3391,7 @@
           <a:p>
             <a:fld id="{259F4B15-8AB2-4C86-B5C5-75A9D4FD84E4}" type="datetimeFigureOut">
               <a:rPr lang="de-DE" smtClean="0"/>
-              <a:t>25.05.2026</a:t>
+              <a:t>26.05.2026</a:t>
             </a:fld>
             <a:endParaRPr lang="de-DE"/>
           </a:p>
@@ -3286,7 +3504,7 @@
           <a:p>
             <a:fld id="{259F4B15-8AB2-4C86-B5C5-75A9D4FD84E4}" type="datetimeFigureOut">
               <a:rPr lang="de-DE" smtClean="0"/>
-              <a:t>25.05.2026</a:t>
+              <a:t>26.05.2026</a:t>
             </a:fld>
             <a:endParaRPr lang="de-DE"/>
           </a:p>
@@ -3597,7 +3815,7 @@
           <a:p>
             <a:fld id="{259F4B15-8AB2-4C86-B5C5-75A9D4FD84E4}" type="datetimeFigureOut">
               <a:rPr lang="de-DE" smtClean="0"/>
-              <a:t>25.05.2026</a:t>
+              <a:t>26.05.2026</a:t>
             </a:fld>
             <a:endParaRPr lang="de-DE"/>
           </a:p>
@@ -3885,7 +4103,7 @@
           <a:p>
             <a:fld id="{259F4B15-8AB2-4C86-B5C5-75A9D4FD84E4}" type="datetimeFigureOut">
               <a:rPr lang="de-DE" smtClean="0"/>
-              <a:t>25.05.2026</a:t>
+              <a:t>26.05.2026</a:t>
             </a:fld>
             <a:endParaRPr lang="de-DE"/>
           </a:p>
@@ -4126,7 +4344,7 @@
           <a:p>
             <a:fld id="{259F4B15-8AB2-4C86-B5C5-75A9D4FD84E4}" type="datetimeFigureOut">
               <a:rPr lang="de-DE" smtClean="0"/>
-              <a:t>25.05.2026</a:t>
+              <a:t>26.05.2026</a:t>
             </a:fld>
             <a:endParaRPr lang="de-DE"/>
           </a:p>
@@ -5256,6 +5474,153 @@
 </p:sld>
 </file>
 
+<file path=ppt/slides/slide10.xml><?xml version="1.0" encoding="utf-8"?>
+<p:sld xmlns:a="http://schemas.openxmlformats.org/drawingml/2006/main" xmlns:r="http://schemas.openxmlformats.org/officeDocument/2006/relationships" xmlns:p="http://schemas.openxmlformats.org/presentationml/2006/main">
+  <p:cSld>
+    <p:spTree>
+      <p:nvGrpSpPr>
+        <p:cNvPr id="1" name=""/>
+        <p:cNvGrpSpPr/>
+        <p:nvPr/>
+      </p:nvGrpSpPr>
+      <p:grpSpPr>
+        <a:xfrm>
+          <a:off x="0" y="0"/>
+          <a:ext cx="0" cy="0"/>
+          <a:chOff x="0" y="0"/>
+          <a:chExt cx="0" cy="0"/>
+        </a:xfrm>
+      </p:grpSpPr>
+      <p:sp>
+        <p:nvSpPr>
+          <p:cNvPr id="2" name="Titel 1">
+            <a:extLst>
+              <a:ext uri="{FF2B5EF4-FFF2-40B4-BE49-F238E27FC236}">
+                <a16:creationId xmlns:a16="http://schemas.microsoft.com/office/drawing/2014/main" id="{FA111BCC-1FCB-797D-6A46-449BCAB31DD4}"/>
+              </a:ext>
+            </a:extLst>
+          </p:cNvPr>
+          <p:cNvSpPr>
+            <a:spLocks noGrp="1"/>
+          </p:cNvSpPr>
+          <p:nvPr>
+            <p:ph type="title"/>
+          </p:nvPr>
+        </p:nvSpPr>
+        <p:spPr/>
+        <p:txBody>
+          <a:bodyPr/>
+          <a:lstStyle/>
+          <a:p>
+            <a:r>
+              <a:rPr lang="de-DE" dirty="0" err="1"/>
+              <a:t>Conclusion</a:t>
+            </a:r>
+            <a:endParaRPr lang="de-DE" dirty="0"/>
+          </a:p>
+        </p:txBody>
+      </p:sp>
+      <p:sp>
+        <p:nvSpPr>
+          <p:cNvPr id="3" name="Inhaltsplatzhalter 2">
+            <a:extLst>
+              <a:ext uri="{FF2B5EF4-FFF2-40B4-BE49-F238E27FC236}">
+                <a16:creationId xmlns:a16="http://schemas.microsoft.com/office/drawing/2014/main" id="{13680EE8-07C5-28E5-EB00-12F747B70BC0}"/>
+              </a:ext>
+            </a:extLst>
+          </p:cNvPr>
+          <p:cNvSpPr>
+            <a:spLocks noGrp="1"/>
+          </p:cNvSpPr>
+          <p:nvPr>
+            <p:ph idx="1"/>
+          </p:nvPr>
+        </p:nvSpPr>
+        <p:spPr/>
+        <p:txBody>
+          <a:bodyPr/>
+          <a:lstStyle/>
+          <a:p>
+            <a:r>
+              <a:rPr lang="de-DE" dirty="0" err="1"/>
+              <a:t>Successful</a:t>
+            </a:r>
+            <a:r>
+              <a:rPr lang="de-DE" dirty="0"/>
+              <a:t> </a:t>
+            </a:r>
+            <a:r>
+              <a:rPr lang="de-DE" dirty="0" err="1"/>
+              <a:t>proof</a:t>
+            </a:r>
+            <a:r>
+              <a:rPr lang="de-DE" dirty="0"/>
+              <a:t> </a:t>
+            </a:r>
+            <a:r>
+              <a:rPr lang="de-DE" dirty="0" err="1"/>
+              <a:t>of</a:t>
+            </a:r>
+            <a:r>
+              <a:rPr lang="de-DE" dirty="0"/>
+              <a:t> </a:t>
+            </a:r>
+            <a:r>
+              <a:rPr lang="de-DE" dirty="0" err="1"/>
+              <a:t>concept</a:t>
+            </a:r>
+            <a:endParaRPr lang="de-DE" dirty="0"/>
+          </a:p>
+          <a:p>
+            <a:r>
+              <a:rPr lang="de-DE" dirty="0"/>
+              <a:t>Speech </a:t>
+            </a:r>
+            <a:r>
+              <a:rPr lang="de-DE" dirty="0" err="1"/>
+              <a:t>as</a:t>
+            </a:r>
+            <a:r>
+              <a:rPr lang="de-DE" dirty="0"/>
+              <a:t> </a:t>
+            </a:r>
+            <a:r>
+              <a:rPr lang="de-DE" dirty="0" err="1"/>
+              <a:t>lightweight</a:t>
+            </a:r>
+            <a:r>
+              <a:rPr lang="de-DE" dirty="0"/>
+              <a:t> interface</a:t>
+            </a:r>
+            <a:endParaRPr lang="en-US" dirty="0"/>
+          </a:p>
+          <a:p>
+            <a:r>
+              <a:rPr lang="en-US" dirty="0"/>
+              <a:t>Real-time control works </a:t>
+            </a:r>
+          </a:p>
+          <a:p>
+            <a:r>
+              <a:rPr lang="en-US" dirty="0"/>
+              <a:t>Reliable command recognition </a:t>
+            </a:r>
+          </a:p>
+        </p:txBody>
+      </p:sp>
+    </p:spTree>
+    <p:extLst>
+      <p:ext uri="{BB962C8B-B14F-4D97-AF65-F5344CB8AC3E}">
+        <p14:creationId xmlns:p14="http://schemas.microsoft.com/office/powerpoint/2010/main" val="3625072128"/>
+      </p:ext>
+    </p:extLst>
+  </p:cSld>
+  <p:clrMapOvr>
+    <a:masterClrMapping/>
+  </p:clrMapOvr>
+</p:sld>
+</file>
+
 <file path=ppt/slides/slide2.xml><?xml version="1.0" encoding="utf-8"?>
 <p:sld xmlns:a="http://schemas.openxmlformats.org/drawingml/2006/main" xmlns:r="http://schemas.openxmlformats.org/officeDocument/2006/relationships" xmlns:p="http://schemas.openxmlformats.org/presentationml/2006/main">
   <p:cSld>
@@ -7548,9 +7913,23 @@
 <file path=ppt/slides/slide7.xml><?xml version="1.0" encoding="utf-8"?>
 <p:sld xmlns:a="http://schemas.openxmlformats.org/drawingml/2006/main" xmlns:r="http://schemas.openxmlformats.org/officeDocument/2006/relationships" xmlns:p="http://schemas.openxmlformats.org/presentationml/2006/main">
   <p:cSld>
+    <p:bg>
+      <p:bgPr>
+        <a:solidFill>
+          <a:schemeClr val="bg1"/>
+        </a:solidFill>
+        <a:effectLst/>
+      </p:bgPr>
+    </p:bg>
     <p:spTree>
       <p:nvGrpSpPr>
-        <p:cNvPr id="1" name=""/>
+        <p:cNvPr id="1" name="">
+          <a:extLst>
+            <a:ext uri="{FF2B5EF4-FFF2-40B4-BE49-F238E27FC236}">
+              <a16:creationId xmlns:a16="http://schemas.microsoft.com/office/drawing/2014/main" id="{CB34A122-7797-DA5A-B347-1451091C335E}"/>
+            </a:ext>
+          </a:extLst>
+        </p:cNvPr>
         <p:cNvGrpSpPr/>
         <p:nvPr/>
       </p:nvGrpSpPr>
@@ -7562,12 +7941,315 @@
           <a:chExt cx="0" cy="0"/>
         </a:xfrm>
       </p:grpSpPr>
-      <p:sp>
-        <p:nvSpPr>
-          <p:cNvPr id="2" name="Titel 1">
-            <a:extLst>
-              <a:ext uri="{FF2B5EF4-FFF2-40B4-BE49-F238E27FC236}">
-                <a16:creationId xmlns:a16="http://schemas.microsoft.com/office/drawing/2014/main" id="{DE91ACC9-79D4-17C2-681B-F78A70151FD9}"/>
+      <p:sp useBgFill="1">
+        <p:nvSpPr>
+          <p:cNvPr id="13" name="Rectangle 12">
+            <a:extLst>
+              <a:ext uri="{FF2B5EF4-FFF2-40B4-BE49-F238E27FC236}">
+                <a16:creationId xmlns:a16="http://schemas.microsoft.com/office/drawing/2014/main" id="{BF1F40FB-18AB-757F-52E2-A5D850BD4022}"/>
+              </a:ext>
+              <a:ext uri="{C183D7F6-B498-43B3-948B-1728B52AA6E4}">
+                <adec:decorative xmlns:adec="http://schemas.microsoft.com/office/drawing/2017/decorative" val="1"/>
+              </a:ext>
+            </a:extLst>
+          </p:cNvPr>
+          <p:cNvSpPr>
+            <a:spLocks noGrp="1" noRot="1" noChangeAspect="1" noMove="1" noResize="1" noEditPoints="1" noAdjustHandles="1" noChangeArrowheads="1" noChangeShapeType="1" noTextEdit="1"/>
+          </p:cNvSpPr>
+          <p:nvPr>
+            <p:extLst>
+              <p:ext uri="{386F3935-93C4-4BCD-93E2-E3B085C9AB24}">
+                <p16:designElem xmlns:p16="http://schemas.microsoft.com/office/powerpoint/2015/main" val="1"/>
+              </p:ext>
+            </p:extLst>
+          </p:nvPr>
+        </p:nvSpPr>
+        <p:spPr>
+          <a:xfrm>
+            <a:off x="0" y="0"/>
+            <a:ext cx="12192000" cy="6858000"/>
+          </a:xfrm>
+          <a:prstGeom prst="rect">
+            <a:avLst/>
+          </a:prstGeom>
+          <a:ln w="12700" cap="flat" cmpd="sng" algn="ctr">
+            <a:noFill/>
+            <a:prstDash val="solid"/>
+            <a:miter lim="800000"/>
+          </a:ln>
+          <a:effectLst/>
+          <a:extLst>
+            <a:ext uri="{91240B29-F687-4F45-9708-019B960494DF}">
+              <a14:hiddenLine xmlns:a14="http://schemas.microsoft.com/office/drawing/2010/main" w="12700" cap="flat" cmpd="sng" algn="ctr">
+                <a:solidFill>
+                  <a:schemeClr val="accent1">
+                    <a:shade val="50000"/>
+                  </a:schemeClr>
+                </a:solidFill>
+                <a:prstDash val="solid"/>
+                <a:miter lim="800000"/>
+              </a14:hiddenLine>
+            </a:ext>
+          </a:extLst>
+        </p:spPr>
+        <p:style>
+          <a:lnRef idx="2">
+            <a:schemeClr val="accent1">
+              <a:shade val="50000"/>
+            </a:schemeClr>
+          </a:lnRef>
+          <a:fillRef idx="1">
+            <a:schemeClr val="accent1"/>
+          </a:fillRef>
+          <a:effectRef idx="0">
+            <a:schemeClr val="accent1"/>
+          </a:effectRef>
+          <a:fontRef idx="minor">
+            <a:schemeClr val="lt1"/>
+          </a:fontRef>
+        </p:style>
+        <p:txBody>
+          <a:bodyPr rtlCol="0" anchor="ctr"/>
+          <a:lstStyle/>
+          <a:p>
+            <a:pPr algn="ctr"/>
+            <a:endParaRPr lang="en-US"/>
+          </a:p>
+        </p:txBody>
+      </p:sp>
+      <p:sp>
+        <p:nvSpPr>
+          <p:cNvPr id="15" name="Rectangle 14">
+            <a:extLst>
+              <a:ext uri="{FF2B5EF4-FFF2-40B4-BE49-F238E27FC236}">
+                <a16:creationId xmlns:a16="http://schemas.microsoft.com/office/drawing/2014/main" id="{C32230C8-DA72-BBD1-07A1-06C4C3B72063}"/>
+              </a:ext>
+              <a:ext uri="{C183D7F6-B498-43B3-948B-1728B52AA6E4}">
+                <adec:decorative xmlns:adec="http://schemas.microsoft.com/office/drawing/2017/decorative" val="1"/>
+              </a:ext>
+            </a:extLst>
+          </p:cNvPr>
+          <p:cNvSpPr>
+            <a:spLocks noGrp="1" noRot="1" noChangeAspect="1" noMove="1" noResize="1" noEditPoints="1" noAdjustHandles="1" noChangeArrowheads="1" noChangeShapeType="1" noTextEdit="1"/>
+          </p:cNvSpPr>
+          <p:nvPr>
+            <p:extLst>
+              <p:ext uri="{386F3935-93C4-4BCD-93E2-E3B085C9AB24}">
+                <p16:designElem xmlns:p16="http://schemas.microsoft.com/office/powerpoint/2015/main" val="1"/>
+              </p:ext>
+            </p:extLst>
+          </p:nvPr>
+        </p:nvSpPr>
+        <p:spPr>
+          <a:xfrm rot="10800000" flipH="1">
+            <a:off x="2" y="0"/>
+            <a:ext cx="12191998" cy="1575955"/>
+          </a:xfrm>
+          <a:prstGeom prst="rect">
+            <a:avLst/>
+          </a:prstGeom>
+          <a:gradFill>
+            <a:gsLst>
+              <a:gs pos="0">
+                <a:srgbClr val="000000">
+                  <a:alpha val="96000"/>
+                </a:srgbClr>
+              </a:gs>
+              <a:gs pos="100000">
+                <a:schemeClr val="accent1">
+                  <a:lumMod val="75000"/>
+                </a:schemeClr>
+              </a:gs>
+            </a:gsLst>
+            <a:lin ang="6000000" scaled="0"/>
+          </a:gradFill>
+          <a:ln>
+            <a:noFill/>
+          </a:ln>
+        </p:spPr>
+        <p:style>
+          <a:lnRef idx="2">
+            <a:schemeClr val="accent1">
+              <a:shade val="50000"/>
+            </a:schemeClr>
+          </a:lnRef>
+          <a:fillRef idx="1">
+            <a:schemeClr val="accent1"/>
+          </a:fillRef>
+          <a:effectRef idx="0">
+            <a:schemeClr val="accent1"/>
+          </a:effectRef>
+          <a:fontRef idx="minor">
+            <a:schemeClr val="lt1"/>
+          </a:fontRef>
+        </p:style>
+        <p:txBody>
+          <a:bodyPr rtlCol="0" anchor="ctr"/>
+          <a:lstStyle/>
+          <a:p>
+            <a:pPr algn="ctr"/>
+            <a:endParaRPr lang="en-US"/>
+          </a:p>
+        </p:txBody>
+      </p:sp>
+      <p:sp>
+        <p:nvSpPr>
+          <p:cNvPr id="17" name="Rectangle 16">
+            <a:extLst>
+              <a:ext uri="{FF2B5EF4-FFF2-40B4-BE49-F238E27FC236}">
+                <a16:creationId xmlns:a16="http://schemas.microsoft.com/office/drawing/2014/main" id="{EB24B9B3-556D-0995-AB5A-1A5793ECA5AF}"/>
+              </a:ext>
+              <a:ext uri="{C183D7F6-B498-43B3-948B-1728B52AA6E4}">
+                <adec:decorative xmlns:adec="http://schemas.microsoft.com/office/drawing/2017/decorative" val="1"/>
+              </a:ext>
+            </a:extLst>
+          </p:cNvPr>
+          <p:cNvSpPr>
+            <a:spLocks noGrp="1" noRot="1" noChangeAspect="1" noMove="1" noResize="1" noEditPoints="1" noAdjustHandles="1" noChangeArrowheads="1" noChangeShapeType="1" noTextEdit="1"/>
+          </p:cNvSpPr>
+          <p:nvPr>
+            <p:extLst>
+              <p:ext uri="{386F3935-93C4-4BCD-93E2-E3B085C9AB24}">
+                <p16:designElem xmlns:p16="http://schemas.microsoft.com/office/powerpoint/2015/main" val="1"/>
+              </p:ext>
+            </p:extLst>
+          </p:nvPr>
+        </p:nvSpPr>
+        <p:spPr>
+          <a:xfrm>
+            <a:off x="0" y="0"/>
+            <a:ext cx="8128856" cy="1575461"/>
+          </a:xfrm>
+          <a:prstGeom prst="rect">
+            <a:avLst/>
+          </a:prstGeom>
+          <a:gradFill>
+            <a:gsLst>
+              <a:gs pos="0">
+                <a:schemeClr val="accent1">
+                  <a:alpha val="41000"/>
+                </a:schemeClr>
+              </a:gs>
+              <a:gs pos="74000">
+                <a:schemeClr val="accent1">
+                  <a:lumMod val="60000"/>
+                  <a:lumOff val="40000"/>
+                  <a:alpha val="0"/>
+                </a:schemeClr>
+              </a:gs>
+            </a:gsLst>
+            <a:lin ang="8400000" scaled="0"/>
+          </a:gradFill>
+          <a:ln>
+            <a:noFill/>
+          </a:ln>
+        </p:spPr>
+        <p:style>
+          <a:lnRef idx="2">
+            <a:schemeClr val="accent1">
+              <a:shade val="50000"/>
+            </a:schemeClr>
+          </a:lnRef>
+          <a:fillRef idx="1">
+            <a:schemeClr val="accent1"/>
+          </a:fillRef>
+          <a:effectRef idx="0">
+            <a:schemeClr val="accent1"/>
+          </a:effectRef>
+          <a:fontRef idx="minor">
+            <a:schemeClr val="lt1"/>
+          </a:fontRef>
+        </p:style>
+        <p:txBody>
+          <a:bodyPr rtlCol="0" anchor="ctr"/>
+          <a:lstStyle/>
+          <a:p>
+            <a:pPr algn="ctr"/>
+            <a:endParaRPr lang="en-US"/>
+          </a:p>
+        </p:txBody>
+      </p:sp>
+      <p:sp>
+        <p:nvSpPr>
+          <p:cNvPr id="19" name="Rectangle 18">
+            <a:extLst>
+              <a:ext uri="{FF2B5EF4-FFF2-40B4-BE49-F238E27FC236}">
+                <a16:creationId xmlns:a16="http://schemas.microsoft.com/office/drawing/2014/main" id="{5EFE942F-C8E6-ABD6-610D-1CEB19DF51DD}"/>
+              </a:ext>
+              <a:ext uri="{C183D7F6-B498-43B3-948B-1728B52AA6E4}">
+                <adec:decorative xmlns:adec="http://schemas.microsoft.com/office/drawing/2017/decorative" val="1"/>
+              </a:ext>
+            </a:extLst>
+          </p:cNvPr>
+          <p:cNvSpPr>
+            <a:spLocks noGrp="1" noRot="1" noChangeAspect="1" noMove="1" noResize="1" noEditPoints="1" noAdjustHandles="1" noChangeArrowheads="1" noChangeShapeType="1" noTextEdit="1"/>
+          </p:cNvSpPr>
+          <p:nvPr>
+            <p:extLst>
+              <p:ext uri="{386F3935-93C4-4BCD-93E2-E3B085C9AB24}">
+                <p16:designElem xmlns:p16="http://schemas.microsoft.com/office/powerpoint/2015/main" val="1"/>
+              </p:ext>
+            </p:extLst>
+          </p:nvPr>
+        </p:nvSpPr>
+        <p:spPr>
+          <a:xfrm flipH="1">
+            <a:off x="-3" y="-1"/>
+            <a:ext cx="12192002" cy="1574311"/>
+          </a:xfrm>
+          <a:prstGeom prst="rect">
+            <a:avLst/>
+          </a:prstGeom>
+          <a:gradFill>
+            <a:gsLst>
+              <a:gs pos="0">
+                <a:srgbClr val="000000">
+                  <a:alpha val="63000"/>
+                </a:srgbClr>
+              </a:gs>
+              <a:gs pos="78000">
+                <a:schemeClr val="accent1">
+                  <a:alpha val="15000"/>
+                </a:schemeClr>
+              </a:gs>
+            </a:gsLst>
+            <a:lin ang="15600000" scaled="0"/>
+          </a:gradFill>
+          <a:ln>
+            <a:noFill/>
+          </a:ln>
+        </p:spPr>
+        <p:style>
+          <a:lnRef idx="2">
+            <a:schemeClr val="accent1">
+              <a:shade val="50000"/>
+            </a:schemeClr>
+          </a:lnRef>
+          <a:fillRef idx="1">
+            <a:schemeClr val="accent1"/>
+          </a:fillRef>
+          <a:effectRef idx="0">
+            <a:schemeClr val="accent1"/>
+          </a:effectRef>
+          <a:fontRef idx="minor">
+            <a:schemeClr val="lt1"/>
+          </a:fontRef>
+        </p:style>
+        <p:txBody>
+          <a:bodyPr rtlCol="0" anchor="ctr"/>
+          <a:lstStyle/>
+          <a:p>
+            <a:pPr algn="ctr"/>
+            <a:endParaRPr lang="en-US"/>
+          </a:p>
+        </p:txBody>
+      </p:sp>
+      <p:sp>
+        <p:nvSpPr>
+          <p:cNvPr id="2" name="Title 1">
+            <a:extLst>
+              <a:ext uri="{FF2B5EF4-FFF2-40B4-BE49-F238E27FC236}">
+                <a16:creationId xmlns:a16="http://schemas.microsoft.com/office/drawing/2014/main" id="{24C08299-A037-119E-EFFC-EE036847024F}"/>
               </a:ext>
             </a:extLst>
           </p:cNvPr>
@@ -7578,29 +8260,43 @@
             <p:ph type="title"/>
           </p:nvPr>
         </p:nvSpPr>
-        <p:spPr/>
-        <p:txBody>
-          <a:bodyPr/>
-          <a:lstStyle/>
-          <a:p>
-            <a:r>
-              <a:rPr lang="de-DE" dirty="0"/>
-              <a:t>System </a:t>
-            </a:r>
-            <a:r>
-              <a:rPr lang="de-DE" dirty="0" err="1"/>
-              <a:t>Overview</a:t>
-            </a:r>
-            <a:endParaRPr lang="de-DE" dirty="0"/>
-          </a:p>
-        </p:txBody>
-      </p:sp>
-      <p:sp>
-        <p:nvSpPr>
-          <p:cNvPr id="3" name="Inhaltsplatzhalter 2">
-            <a:extLst>
-              <a:ext uri="{FF2B5EF4-FFF2-40B4-BE49-F238E27FC236}">
-                <a16:creationId xmlns:a16="http://schemas.microsoft.com/office/drawing/2014/main" id="{DAB83250-174B-4DC9-6B1F-0F086478514B}"/>
+        <p:spPr>
+          <a:xfrm>
+            <a:off x="699713" y="248038"/>
+            <a:ext cx="7063721" cy="1159200"/>
+          </a:xfrm>
+        </p:spPr>
+        <p:txBody>
+          <a:bodyPr vert="horz" lIns="91440" tIns="45720" rIns="91440" bIns="45720" rtlCol="0" anchor="ctr">
+            <a:normAutofit/>
+          </a:bodyPr>
+          <a:lstStyle/>
+          <a:p>
+            <a:r>
+              <a:rPr lang="en-GB" sz="4000" dirty="0">
+                <a:solidFill>
+                  <a:schemeClr val="bg1"/>
+                </a:solidFill>
+              </a:rPr>
+              <a:t>Game integration</a:t>
+            </a:r>
+            <a:endParaRPr lang="en-US" sz="4000" kern="1200" dirty="0">
+              <a:solidFill>
+                <a:schemeClr val="bg1"/>
+              </a:solidFill>
+              <a:latin typeface="+mj-lt"/>
+              <a:ea typeface="+mj-ea"/>
+              <a:cs typeface="+mj-cs"/>
+            </a:endParaRPr>
+          </a:p>
+        </p:txBody>
+      </p:sp>
+      <p:sp>
+        <p:nvSpPr>
+          <p:cNvPr id="3" name="Content Placeholder 2">
+            <a:extLst>
+              <a:ext uri="{FF2B5EF4-FFF2-40B4-BE49-F238E27FC236}">
+                <a16:creationId xmlns:a16="http://schemas.microsoft.com/office/drawing/2014/main" id="{25DEF4F3-5AA0-C4A7-F9EA-33A485BF28C3}"/>
               </a:ext>
             </a:extLst>
           </p:cNvPr>
@@ -7611,43 +8307,104 @@
             <p:ph idx="1"/>
           </p:nvPr>
         </p:nvSpPr>
-        <p:spPr/>
-        <p:txBody>
-          <a:bodyPr/>
-          <a:lstStyle/>
-          <a:p>
-            <a:r>
-              <a:rPr lang="en-US" dirty="0"/>
-              <a:t>Audio input </a:t>
-            </a:r>
-          </a:p>
-          <a:p>
-            <a:r>
-              <a:rPr lang="en-US" dirty="0"/>
-              <a:t>MFCC feature extraction </a:t>
-            </a:r>
-          </a:p>
-          <a:p>
-            <a:r>
-              <a:rPr lang="en-US" dirty="0"/>
-              <a:t>DNN + HMM processing </a:t>
-            </a:r>
-          </a:p>
-          <a:p>
-            <a:r>
-              <a:rPr lang="en-US" dirty="0"/>
-              <a:t>Word prediction</a:t>
-            </a:r>
-          </a:p>
-          <a:p>
-            <a:endParaRPr lang="de-DE" dirty="0"/>
+        <p:spPr>
+          <a:xfrm>
+            <a:off x="6047084" y="1899919"/>
+            <a:ext cx="5623560" cy="1056641"/>
+          </a:xfrm>
+        </p:spPr>
+        <p:txBody>
+          <a:bodyPr>
+            <a:normAutofit/>
+          </a:bodyPr>
+          <a:lstStyle/>
+          <a:p>
+            <a:r>
+              <a:rPr lang="en-GB" dirty="0"/>
+              <a:t>recursive backtracking maze generation</a:t>
+            </a:r>
+          </a:p>
+        </p:txBody>
+      </p:sp>
+      <p:pic>
+        <p:nvPicPr>
+          <p:cNvPr id="6" name="Picture 5">
+            <a:extLst>
+              <a:ext uri="{FF2B5EF4-FFF2-40B4-BE49-F238E27FC236}">
+                <a16:creationId xmlns:a16="http://schemas.microsoft.com/office/drawing/2014/main" id="{075156BD-F60A-FF0C-227C-6D7E339C9026}"/>
+              </a:ext>
+            </a:extLst>
+          </p:cNvPr>
+          <p:cNvPicPr>
+            <a:picLocks noChangeAspect="1"/>
+          </p:cNvPicPr>
+          <p:nvPr/>
+        </p:nvPicPr>
+        <p:blipFill>
+          <a:blip r:embed="rId3"/>
+          <a:srcRect t="2536"/>
+          <a:stretch>
+            <a:fillRect/>
+          </a:stretch>
+        </p:blipFill>
+        <p:spPr>
+          <a:xfrm>
+            <a:off x="699713" y="1765887"/>
+            <a:ext cx="4820920" cy="4844075"/>
+          </a:xfrm>
+          <a:prstGeom prst="rect">
+            <a:avLst/>
+          </a:prstGeom>
+        </p:spPr>
+      </p:pic>
+      <p:sp>
+        <p:nvSpPr>
+          <p:cNvPr id="8" name="TextBox 7">
+            <a:extLst>
+              <a:ext uri="{FF2B5EF4-FFF2-40B4-BE49-F238E27FC236}">
+                <a16:creationId xmlns:a16="http://schemas.microsoft.com/office/drawing/2014/main" id="{0C01C29D-DED3-AC37-489D-99100642E287}"/>
+              </a:ext>
+            </a:extLst>
+          </p:cNvPr>
+          <p:cNvSpPr txBox="1"/>
+          <p:nvPr/>
+        </p:nvSpPr>
+        <p:spPr>
+          <a:xfrm>
+            <a:off x="6502400" y="2956560"/>
+            <a:ext cx="4307840" cy="1200329"/>
+          </a:xfrm>
+          <a:prstGeom prst="rect">
+            <a:avLst/>
+          </a:prstGeom>
+          <a:noFill/>
+        </p:spPr>
+        <p:txBody>
+          <a:bodyPr wrap="square" rtlCol="0">
+            <a:spAutoFit/>
+          </a:bodyPr>
+          <a:lstStyle/>
+          <a:p>
+            <a:r>
+              <a:rPr lang="en-GB" dirty="0"/>
+              <a:t>1- initialize maze with walls everywhere </a:t>
+            </a:r>
+          </a:p>
+          <a:p>
+            <a:endParaRPr lang="en-GB" dirty="0"/>
+          </a:p>
+          <a:p>
+            <a:r>
+              <a:rPr lang="en-GB" dirty="0"/>
+              <a:t>2- do a depth first search while removing the walls between neighbours </a:t>
+            </a:r>
           </a:p>
         </p:txBody>
       </p:sp>
     </p:spTree>
     <p:extLst>
       <p:ext uri="{BB962C8B-B14F-4D97-AF65-F5344CB8AC3E}">
-        <p14:creationId xmlns:p14="http://schemas.microsoft.com/office/powerpoint/2010/main" val="466913703"/>
+        <p14:creationId xmlns:p14="http://schemas.microsoft.com/office/powerpoint/2010/main" val="125624488"/>
       </p:ext>
     </p:extLst>
   </p:cSld>
@@ -7658,6 +8415,749 @@
 </file>
 
 <file path=ppt/slides/slide8.xml><?xml version="1.0" encoding="utf-8"?>
+<p:sld xmlns:a="http://schemas.openxmlformats.org/drawingml/2006/main" xmlns:r="http://schemas.openxmlformats.org/officeDocument/2006/relationships" xmlns:p="http://schemas.openxmlformats.org/presentationml/2006/main">
+  <p:cSld>
+    <p:bg>
+      <p:bgPr>
+        <a:solidFill>
+          <a:schemeClr val="bg1"/>
+        </a:solidFill>
+        <a:effectLst/>
+      </p:bgPr>
+    </p:bg>
+    <p:spTree>
+      <p:nvGrpSpPr>
+        <p:cNvPr id="1" name="">
+          <a:extLst>
+            <a:ext uri="{FF2B5EF4-FFF2-40B4-BE49-F238E27FC236}">
+              <a16:creationId xmlns:a16="http://schemas.microsoft.com/office/drawing/2014/main" id="{A99956A7-46B4-9625-F3E4-A95F35906949}"/>
+            </a:ext>
+          </a:extLst>
+        </p:cNvPr>
+        <p:cNvGrpSpPr/>
+        <p:nvPr/>
+      </p:nvGrpSpPr>
+      <p:grpSpPr>
+        <a:xfrm>
+          <a:off x="0" y="0"/>
+          <a:ext cx="0" cy="0"/>
+          <a:chOff x="0" y="0"/>
+          <a:chExt cx="0" cy="0"/>
+        </a:xfrm>
+      </p:grpSpPr>
+      <p:sp useBgFill="1">
+        <p:nvSpPr>
+          <p:cNvPr id="13" name="Rectangle 12">
+            <a:extLst>
+              <a:ext uri="{FF2B5EF4-FFF2-40B4-BE49-F238E27FC236}">
+                <a16:creationId xmlns:a16="http://schemas.microsoft.com/office/drawing/2014/main" id="{9D474B9D-F108-890B-7F40-677FA49E91B7}"/>
+              </a:ext>
+              <a:ext uri="{C183D7F6-B498-43B3-948B-1728B52AA6E4}">
+                <adec:decorative xmlns:adec="http://schemas.microsoft.com/office/drawing/2017/decorative" val="1"/>
+              </a:ext>
+            </a:extLst>
+          </p:cNvPr>
+          <p:cNvSpPr>
+            <a:spLocks noGrp="1" noRot="1" noChangeAspect="1" noMove="1" noResize="1" noEditPoints="1" noAdjustHandles="1" noChangeArrowheads="1" noChangeShapeType="1" noTextEdit="1"/>
+          </p:cNvSpPr>
+          <p:nvPr>
+            <p:extLst>
+              <p:ext uri="{386F3935-93C4-4BCD-93E2-E3B085C9AB24}">
+                <p16:designElem xmlns:p16="http://schemas.microsoft.com/office/powerpoint/2015/main" val="1"/>
+              </p:ext>
+            </p:extLst>
+          </p:nvPr>
+        </p:nvSpPr>
+        <p:spPr>
+          <a:xfrm>
+            <a:off x="0" y="0"/>
+            <a:ext cx="12192000" cy="6858000"/>
+          </a:xfrm>
+          <a:prstGeom prst="rect">
+            <a:avLst/>
+          </a:prstGeom>
+          <a:ln w="12700" cap="flat" cmpd="sng" algn="ctr">
+            <a:noFill/>
+            <a:prstDash val="solid"/>
+            <a:miter lim="800000"/>
+          </a:ln>
+          <a:effectLst/>
+          <a:extLst>
+            <a:ext uri="{91240B29-F687-4F45-9708-019B960494DF}">
+              <a14:hiddenLine xmlns:a14="http://schemas.microsoft.com/office/drawing/2010/main" w="12700" cap="flat" cmpd="sng" algn="ctr">
+                <a:solidFill>
+                  <a:schemeClr val="accent1">
+                    <a:shade val="50000"/>
+                  </a:schemeClr>
+                </a:solidFill>
+                <a:prstDash val="solid"/>
+                <a:miter lim="800000"/>
+              </a14:hiddenLine>
+            </a:ext>
+          </a:extLst>
+        </p:spPr>
+        <p:style>
+          <a:lnRef idx="2">
+            <a:schemeClr val="accent1">
+              <a:shade val="50000"/>
+            </a:schemeClr>
+          </a:lnRef>
+          <a:fillRef idx="1">
+            <a:schemeClr val="accent1"/>
+          </a:fillRef>
+          <a:effectRef idx="0">
+            <a:schemeClr val="accent1"/>
+          </a:effectRef>
+          <a:fontRef idx="minor">
+            <a:schemeClr val="lt1"/>
+          </a:fontRef>
+        </p:style>
+        <p:txBody>
+          <a:bodyPr rtlCol="0" anchor="ctr"/>
+          <a:lstStyle/>
+          <a:p>
+            <a:pPr algn="ctr"/>
+            <a:endParaRPr lang="en-US"/>
+          </a:p>
+        </p:txBody>
+      </p:sp>
+      <p:sp>
+        <p:nvSpPr>
+          <p:cNvPr id="15" name="Rectangle 14">
+            <a:extLst>
+              <a:ext uri="{FF2B5EF4-FFF2-40B4-BE49-F238E27FC236}">
+                <a16:creationId xmlns:a16="http://schemas.microsoft.com/office/drawing/2014/main" id="{8F7C90E5-F183-A269-4E23-2DA300B26169}"/>
+              </a:ext>
+              <a:ext uri="{C183D7F6-B498-43B3-948B-1728B52AA6E4}">
+                <adec:decorative xmlns:adec="http://schemas.microsoft.com/office/drawing/2017/decorative" val="1"/>
+              </a:ext>
+            </a:extLst>
+          </p:cNvPr>
+          <p:cNvSpPr>
+            <a:spLocks noGrp="1" noRot="1" noChangeAspect="1" noMove="1" noResize="1" noEditPoints="1" noAdjustHandles="1" noChangeArrowheads="1" noChangeShapeType="1" noTextEdit="1"/>
+          </p:cNvSpPr>
+          <p:nvPr>
+            <p:extLst>
+              <p:ext uri="{386F3935-93C4-4BCD-93E2-E3B085C9AB24}">
+                <p16:designElem xmlns:p16="http://schemas.microsoft.com/office/powerpoint/2015/main" val="1"/>
+              </p:ext>
+            </p:extLst>
+          </p:nvPr>
+        </p:nvSpPr>
+        <p:spPr>
+          <a:xfrm rot="10800000" flipH="1">
+            <a:off x="2" y="0"/>
+            <a:ext cx="12191998" cy="1575955"/>
+          </a:xfrm>
+          <a:prstGeom prst="rect">
+            <a:avLst/>
+          </a:prstGeom>
+          <a:gradFill>
+            <a:gsLst>
+              <a:gs pos="0">
+                <a:srgbClr val="000000">
+                  <a:alpha val="96000"/>
+                </a:srgbClr>
+              </a:gs>
+              <a:gs pos="100000">
+                <a:schemeClr val="accent1">
+                  <a:lumMod val="75000"/>
+                </a:schemeClr>
+              </a:gs>
+            </a:gsLst>
+            <a:lin ang="6000000" scaled="0"/>
+          </a:gradFill>
+          <a:ln>
+            <a:noFill/>
+          </a:ln>
+        </p:spPr>
+        <p:style>
+          <a:lnRef idx="2">
+            <a:schemeClr val="accent1">
+              <a:shade val="50000"/>
+            </a:schemeClr>
+          </a:lnRef>
+          <a:fillRef idx="1">
+            <a:schemeClr val="accent1"/>
+          </a:fillRef>
+          <a:effectRef idx="0">
+            <a:schemeClr val="accent1"/>
+          </a:effectRef>
+          <a:fontRef idx="minor">
+            <a:schemeClr val="lt1"/>
+          </a:fontRef>
+        </p:style>
+        <p:txBody>
+          <a:bodyPr rtlCol="0" anchor="ctr"/>
+          <a:lstStyle/>
+          <a:p>
+            <a:pPr algn="ctr"/>
+            <a:endParaRPr lang="en-US"/>
+          </a:p>
+        </p:txBody>
+      </p:sp>
+      <p:sp>
+        <p:nvSpPr>
+          <p:cNvPr id="17" name="Rectangle 16">
+            <a:extLst>
+              <a:ext uri="{FF2B5EF4-FFF2-40B4-BE49-F238E27FC236}">
+                <a16:creationId xmlns:a16="http://schemas.microsoft.com/office/drawing/2014/main" id="{05B3C5F7-A888-EB15-E4B6-F64EBF0A5073}"/>
+              </a:ext>
+              <a:ext uri="{C183D7F6-B498-43B3-948B-1728B52AA6E4}">
+                <adec:decorative xmlns:adec="http://schemas.microsoft.com/office/drawing/2017/decorative" val="1"/>
+              </a:ext>
+            </a:extLst>
+          </p:cNvPr>
+          <p:cNvSpPr>
+            <a:spLocks noGrp="1" noRot="1" noChangeAspect="1" noMove="1" noResize="1" noEditPoints="1" noAdjustHandles="1" noChangeArrowheads="1" noChangeShapeType="1" noTextEdit="1"/>
+          </p:cNvSpPr>
+          <p:nvPr>
+            <p:extLst>
+              <p:ext uri="{386F3935-93C4-4BCD-93E2-E3B085C9AB24}">
+                <p16:designElem xmlns:p16="http://schemas.microsoft.com/office/powerpoint/2015/main" val="1"/>
+              </p:ext>
+            </p:extLst>
+          </p:nvPr>
+        </p:nvSpPr>
+        <p:spPr>
+          <a:xfrm>
+            <a:off x="0" y="0"/>
+            <a:ext cx="8128856" cy="1575461"/>
+          </a:xfrm>
+          <a:prstGeom prst="rect">
+            <a:avLst/>
+          </a:prstGeom>
+          <a:gradFill>
+            <a:gsLst>
+              <a:gs pos="0">
+                <a:schemeClr val="accent1">
+                  <a:alpha val="41000"/>
+                </a:schemeClr>
+              </a:gs>
+              <a:gs pos="74000">
+                <a:schemeClr val="accent1">
+                  <a:lumMod val="60000"/>
+                  <a:lumOff val="40000"/>
+                  <a:alpha val="0"/>
+                </a:schemeClr>
+              </a:gs>
+            </a:gsLst>
+            <a:lin ang="8400000" scaled="0"/>
+          </a:gradFill>
+          <a:ln>
+            <a:noFill/>
+          </a:ln>
+        </p:spPr>
+        <p:style>
+          <a:lnRef idx="2">
+            <a:schemeClr val="accent1">
+              <a:shade val="50000"/>
+            </a:schemeClr>
+          </a:lnRef>
+          <a:fillRef idx="1">
+            <a:schemeClr val="accent1"/>
+          </a:fillRef>
+          <a:effectRef idx="0">
+            <a:schemeClr val="accent1"/>
+          </a:effectRef>
+          <a:fontRef idx="minor">
+            <a:schemeClr val="lt1"/>
+          </a:fontRef>
+        </p:style>
+        <p:txBody>
+          <a:bodyPr rtlCol="0" anchor="ctr"/>
+          <a:lstStyle/>
+          <a:p>
+            <a:pPr algn="ctr"/>
+            <a:endParaRPr lang="en-US"/>
+          </a:p>
+        </p:txBody>
+      </p:sp>
+      <p:sp>
+        <p:nvSpPr>
+          <p:cNvPr id="19" name="Rectangle 18">
+            <a:extLst>
+              <a:ext uri="{FF2B5EF4-FFF2-40B4-BE49-F238E27FC236}">
+                <a16:creationId xmlns:a16="http://schemas.microsoft.com/office/drawing/2014/main" id="{F3F6812B-1151-3841-2C70-DFB38E78B24D}"/>
+              </a:ext>
+              <a:ext uri="{C183D7F6-B498-43B3-948B-1728B52AA6E4}">
+                <adec:decorative xmlns:adec="http://schemas.microsoft.com/office/drawing/2017/decorative" val="1"/>
+              </a:ext>
+            </a:extLst>
+          </p:cNvPr>
+          <p:cNvSpPr>
+            <a:spLocks noGrp="1" noRot="1" noChangeAspect="1" noMove="1" noResize="1" noEditPoints="1" noAdjustHandles="1" noChangeArrowheads="1" noChangeShapeType="1" noTextEdit="1"/>
+          </p:cNvSpPr>
+          <p:nvPr>
+            <p:extLst>
+              <p:ext uri="{386F3935-93C4-4BCD-93E2-E3B085C9AB24}">
+                <p16:designElem xmlns:p16="http://schemas.microsoft.com/office/powerpoint/2015/main" val="1"/>
+              </p:ext>
+            </p:extLst>
+          </p:nvPr>
+        </p:nvSpPr>
+        <p:spPr>
+          <a:xfrm flipH="1">
+            <a:off x="-3" y="-1"/>
+            <a:ext cx="12192002" cy="1574311"/>
+          </a:xfrm>
+          <a:prstGeom prst="rect">
+            <a:avLst/>
+          </a:prstGeom>
+          <a:gradFill>
+            <a:gsLst>
+              <a:gs pos="0">
+                <a:srgbClr val="000000">
+                  <a:alpha val="63000"/>
+                </a:srgbClr>
+              </a:gs>
+              <a:gs pos="78000">
+                <a:schemeClr val="accent1">
+                  <a:alpha val="15000"/>
+                </a:schemeClr>
+              </a:gs>
+            </a:gsLst>
+            <a:lin ang="15600000" scaled="0"/>
+          </a:gradFill>
+          <a:ln>
+            <a:noFill/>
+          </a:ln>
+        </p:spPr>
+        <p:style>
+          <a:lnRef idx="2">
+            <a:schemeClr val="accent1">
+              <a:shade val="50000"/>
+            </a:schemeClr>
+          </a:lnRef>
+          <a:fillRef idx="1">
+            <a:schemeClr val="accent1"/>
+          </a:fillRef>
+          <a:effectRef idx="0">
+            <a:schemeClr val="accent1"/>
+          </a:effectRef>
+          <a:fontRef idx="minor">
+            <a:schemeClr val="lt1"/>
+          </a:fontRef>
+        </p:style>
+        <p:txBody>
+          <a:bodyPr rtlCol="0" anchor="ctr"/>
+          <a:lstStyle/>
+          <a:p>
+            <a:pPr algn="ctr"/>
+            <a:endParaRPr lang="en-US"/>
+          </a:p>
+        </p:txBody>
+      </p:sp>
+      <p:sp>
+        <p:nvSpPr>
+          <p:cNvPr id="2" name="Title 1">
+            <a:extLst>
+              <a:ext uri="{FF2B5EF4-FFF2-40B4-BE49-F238E27FC236}">
+                <a16:creationId xmlns:a16="http://schemas.microsoft.com/office/drawing/2014/main" id="{CE91FCD4-D558-EC04-D133-F00AA2F7A2EC}"/>
+              </a:ext>
+            </a:extLst>
+          </p:cNvPr>
+          <p:cNvSpPr>
+            <a:spLocks noGrp="1"/>
+          </p:cNvSpPr>
+          <p:nvPr>
+            <p:ph type="title"/>
+          </p:nvPr>
+        </p:nvSpPr>
+        <p:spPr>
+          <a:xfrm>
+            <a:off x="699713" y="248038"/>
+            <a:ext cx="7063721" cy="1159200"/>
+          </a:xfrm>
+        </p:spPr>
+        <p:txBody>
+          <a:bodyPr vert="horz" lIns="91440" tIns="45720" rIns="91440" bIns="45720" rtlCol="0" anchor="ctr">
+            <a:normAutofit/>
+          </a:bodyPr>
+          <a:lstStyle/>
+          <a:p>
+            <a:r>
+              <a:rPr lang="en-GB" sz="4000" dirty="0">
+                <a:solidFill>
+                  <a:schemeClr val="bg1"/>
+                </a:solidFill>
+              </a:rPr>
+              <a:t>Game integration</a:t>
+            </a:r>
+            <a:endParaRPr lang="en-US" sz="4000" kern="1200" dirty="0">
+              <a:solidFill>
+                <a:schemeClr val="bg1"/>
+              </a:solidFill>
+              <a:latin typeface="+mj-lt"/>
+              <a:ea typeface="+mj-ea"/>
+              <a:cs typeface="+mj-cs"/>
+            </a:endParaRPr>
+          </a:p>
+        </p:txBody>
+      </p:sp>
+      <p:pic>
+        <p:nvPicPr>
+          <p:cNvPr id="6" name="Picture 5">
+            <a:extLst>
+              <a:ext uri="{FF2B5EF4-FFF2-40B4-BE49-F238E27FC236}">
+                <a16:creationId xmlns:a16="http://schemas.microsoft.com/office/drawing/2014/main" id="{27351AA0-1576-AF35-533F-93138789F743}"/>
+              </a:ext>
+            </a:extLst>
+          </p:cNvPr>
+          <p:cNvPicPr>
+            <a:picLocks noChangeAspect="1"/>
+          </p:cNvPicPr>
+          <p:nvPr/>
+        </p:nvPicPr>
+        <p:blipFill>
+          <a:blip r:embed="rId3"/>
+          <a:srcRect t="2536"/>
+          <a:stretch>
+            <a:fillRect/>
+          </a:stretch>
+        </p:blipFill>
+        <p:spPr>
+          <a:xfrm>
+            <a:off x="699713" y="1765887"/>
+            <a:ext cx="4820920" cy="4844075"/>
+          </a:xfrm>
+          <a:prstGeom prst="rect">
+            <a:avLst/>
+          </a:prstGeom>
+        </p:spPr>
+      </p:pic>
+      <p:pic>
+        <p:nvPicPr>
+          <p:cNvPr id="9" name="Picture 8">
+            <a:extLst>
+              <a:ext uri="{FF2B5EF4-FFF2-40B4-BE49-F238E27FC236}">
+                <a16:creationId xmlns:a16="http://schemas.microsoft.com/office/drawing/2014/main" id="{B2C0A6C8-5D43-92EB-EA16-424655F4349C}"/>
+              </a:ext>
+            </a:extLst>
+          </p:cNvPr>
+          <p:cNvPicPr>
+            <a:picLocks noChangeAspect="1"/>
+          </p:cNvPicPr>
+          <p:nvPr/>
+        </p:nvPicPr>
+        <p:blipFill>
+          <a:blip r:embed="rId4"/>
+          <a:stretch>
+            <a:fillRect/>
+          </a:stretch>
+        </p:blipFill>
+        <p:spPr>
+          <a:xfrm>
+            <a:off x="699713" y="1763082"/>
+            <a:ext cx="4793253" cy="4787614"/>
+          </a:xfrm>
+          <a:prstGeom prst="rect">
+            <a:avLst/>
+          </a:prstGeom>
+        </p:spPr>
+      </p:pic>
+      <p:grpSp>
+        <p:nvGrpSpPr>
+          <p:cNvPr id="26" name="Group 25">
+            <a:extLst>
+              <a:ext uri="{FF2B5EF4-FFF2-40B4-BE49-F238E27FC236}">
+                <a16:creationId xmlns:a16="http://schemas.microsoft.com/office/drawing/2014/main" id="{00292793-C6BB-C7E6-D6CF-E3A7CA90A6E1}"/>
+              </a:ext>
+            </a:extLst>
+          </p:cNvPr>
+          <p:cNvGrpSpPr/>
+          <p:nvPr/>
+        </p:nvGrpSpPr>
+        <p:grpSpPr>
+          <a:xfrm>
+            <a:off x="7677756" y="2764529"/>
+            <a:ext cx="2357120" cy="3553688"/>
+            <a:chOff x="8016240" y="2316480"/>
+            <a:chExt cx="2357120" cy="3553688"/>
+          </a:xfrm>
+        </p:grpSpPr>
+        <p:sp>
+          <p:nvSpPr>
+            <p:cNvPr id="12" name="Rectangle: Rounded Corners 11">
+              <a:extLst>
+                <a:ext uri="{FF2B5EF4-FFF2-40B4-BE49-F238E27FC236}">
+                  <a16:creationId xmlns:a16="http://schemas.microsoft.com/office/drawing/2014/main" id="{C0D50266-3730-1F07-FC3C-3BF65A9C53F5}"/>
+                </a:ext>
+              </a:extLst>
+            </p:cNvPr>
+            <p:cNvSpPr/>
+            <p:nvPr/>
+          </p:nvSpPr>
+          <p:spPr>
+            <a:xfrm>
+              <a:off x="8016240" y="2316480"/>
+              <a:ext cx="2357120" cy="690880"/>
+            </a:xfrm>
+            <a:prstGeom prst="roundRect">
+              <a:avLst/>
+            </a:prstGeom>
+          </p:spPr>
+          <p:style>
+            <a:lnRef idx="2">
+              <a:schemeClr val="accent1">
+                <a:shade val="15000"/>
+              </a:schemeClr>
+            </a:lnRef>
+            <a:fillRef idx="1">
+              <a:schemeClr val="accent1"/>
+            </a:fillRef>
+            <a:effectRef idx="0">
+              <a:schemeClr val="accent1"/>
+            </a:effectRef>
+            <a:fontRef idx="minor">
+              <a:schemeClr val="lt1"/>
+            </a:fontRef>
+          </p:style>
+          <p:txBody>
+            <a:bodyPr rtlCol="0" anchor="ctr"/>
+            <a:lstStyle/>
+            <a:p>
+              <a:pPr algn="ctr"/>
+              <a:r>
+                <a:rPr lang="en-GB" dirty="0"/>
+                <a:t>speech</a:t>
+              </a:r>
+            </a:p>
+          </p:txBody>
+        </p:sp>
+        <p:sp>
+          <p:nvSpPr>
+            <p:cNvPr id="14" name="Rectangle: Rounded Corners 13">
+              <a:extLst>
+                <a:ext uri="{FF2B5EF4-FFF2-40B4-BE49-F238E27FC236}">
+                  <a16:creationId xmlns:a16="http://schemas.microsoft.com/office/drawing/2014/main" id="{478BA6BF-FF76-4C3A-8CCC-5845A0A51F06}"/>
+                </a:ext>
+              </a:extLst>
+            </p:cNvPr>
+            <p:cNvSpPr/>
+            <p:nvPr/>
+          </p:nvSpPr>
+          <p:spPr>
+            <a:xfrm>
+              <a:off x="8016240" y="3747884"/>
+              <a:ext cx="2357120" cy="690880"/>
+            </a:xfrm>
+            <a:prstGeom prst="roundRect">
+              <a:avLst/>
+            </a:prstGeom>
+          </p:spPr>
+          <p:style>
+            <a:lnRef idx="2">
+              <a:schemeClr val="accent1">
+                <a:shade val="15000"/>
+              </a:schemeClr>
+            </a:lnRef>
+            <a:fillRef idx="1">
+              <a:schemeClr val="accent1"/>
+            </a:fillRef>
+            <a:effectRef idx="0">
+              <a:schemeClr val="accent1"/>
+            </a:effectRef>
+            <a:fontRef idx="minor">
+              <a:schemeClr val="lt1"/>
+            </a:fontRef>
+          </p:style>
+          <p:txBody>
+            <a:bodyPr rtlCol="0" anchor="ctr"/>
+            <a:lstStyle/>
+            <a:p>
+              <a:pPr algn="ctr"/>
+              <a:r>
+                <a:rPr lang="en-GB" dirty="0"/>
+                <a:t>text</a:t>
+              </a:r>
+            </a:p>
+          </p:txBody>
+        </p:sp>
+        <p:sp>
+          <p:nvSpPr>
+            <p:cNvPr id="16" name="Rectangle: Rounded Corners 15">
+              <a:extLst>
+                <a:ext uri="{FF2B5EF4-FFF2-40B4-BE49-F238E27FC236}">
+                  <a16:creationId xmlns:a16="http://schemas.microsoft.com/office/drawing/2014/main" id="{E42F8C2E-C7C1-06C3-0418-EF1626B841F7}"/>
+                </a:ext>
+              </a:extLst>
+            </p:cNvPr>
+            <p:cNvSpPr/>
+            <p:nvPr/>
+          </p:nvSpPr>
+          <p:spPr>
+            <a:xfrm>
+              <a:off x="8016240" y="5179288"/>
+              <a:ext cx="2357120" cy="690880"/>
+            </a:xfrm>
+            <a:prstGeom prst="roundRect">
+              <a:avLst/>
+            </a:prstGeom>
+          </p:spPr>
+          <p:style>
+            <a:lnRef idx="2">
+              <a:schemeClr val="accent1">
+                <a:shade val="15000"/>
+              </a:schemeClr>
+            </a:lnRef>
+            <a:fillRef idx="1">
+              <a:schemeClr val="accent1"/>
+            </a:fillRef>
+            <a:effectRef idx="0">
+              <a:schemeClr val="accent1"/>
+            </a:effectRef>
+            <a:fontRef idx="minor">
+              <a:schemeClr val="lt1"/>
+            </a:fontRef>
+          </p:style>
+          <p:txBody>
+            <a:bodyPr rtlCol="0" anchor="ctr"/>
+            <a:lstStyle/>
+            <a:p>
+              <a:pPr algn="ctr"/>
+              <a:r>
+                <a:rPr lang="en-GB" dirty="0"/>
+                <a:t>direction</a:t>
+              </a:r>
+            </a:p>
+          </p:txBody>
+        </p:sp>
+        <p:cxnSp>
+          <p:nvCxnSpPr>
+            <p:cNvPr id="20" name="Straight Arrow Connector 19">
+              <a:extLst>
+                <a:ext uri="{FF2B5EF4-FFF2-40B4-BE49-F238E27FC236}">
+                  <a16:creationId xmlns:a16="http://schemas.microsoft.com/office/drawing/2014/main" id="{1C522B68-A831-E4C1-3F07-A07D02117E82}"/>
+                </a:ext>
+              </a:extLst>
+            </p:cNvPr>
+            <p:cNvCxnSpPr>
+              <a:stCxn id="12" idx="2"/>
+              <a:endCxn id="14" idx="0"/>
+            </p:cNvCxnSpPr>
+            <p:nvPr/>
+          </p:nvCxnSpPr>
+          <p:spPr>
+            <a:xfrm>
+              <a:off x="9194800" y="3007360"/>
+              <a:ext cx="0" cy="740524"/>
+            </a:xfrm>
+            <a:prstGeom prst="straightConnector1">
+              <a:avLst/>
+            </a:prstGeom>
+            <a:ln>
+              <a:tailEnd type="triangle"/>
+            </a:ln>
+          </p:spPr>
+          <p:style>
+            <a:lnRef idx="2">
+              <a:schemeClr val="accent1"/>
+            </a:lnRef>
+            <a:fillRef idx="0">
+              <a:schemeClr val="accent1"/>
+            </a:fillRef>
+            <a:effectRef idx="1">
+              <a:schemeClr val="accent1"/>
+            </a:effectRef>
+            <a:fontRef idx="minor">
+              <a:schemeClr val="tx1"/>
+            </a:fontRef>
+          </p:style>
+        </p:cxnSp>
+        <p:cxnSp>
+          <p:nvCxnSpPr>
+            <p:cNvPr id="24" name="Straight Arrow Connector 23">
+              <a:extLst>
+                <a:ext uri="{FF2B5EF4-FFF2-40B4-BE49-F238E27FC236}">
+                  <a16:creationId xmlns:a16="http://schemas.microsoft.com/office/drawing/2014/main" id="{0CB9133D-E143-A3C3-F85C-24675FB91EAF}"/>
+                </a:ext>
+              </a:extLst>
+            </p:cNvPr>
+            <p:cNvCxnSpPr>
+              <a:stCxn id="14" idx="2"/>
+              <a:endCxn id="16" idx="0"/>
+            </p:cNvCxnSpPr>
+            <p:nvPr/>
+          </p:nvCxnSpPr>
+          <p:spPr>
+            <a:xfrm>
+              <a:off x="9194800" y="4438764"/>
+              <a:ext cx="0" cy="740524"/>
+            </a:xfrm>
+            <a:prstGeom prst="straightConnector1">
+              <a:avLst/>
+            </a:prstGeom>
+            <a:ln>
+              <a:tailEnd type="triangle"/>
+            </a:ln>
+          </p:spPr>
+          <p:style>
+            <a:lnRef idx="2">
+              <a:schemeClr val="accent1"/>
+            </a:lnRef>
+            <a:fillRef idx="0">
+              <a:schemeClr val="accent1"/>
+            </a:fillRef>
+            <a:effectRef idx="1">
+              <a:schemeClr val="accent1"/>
+            </a:effectRef>
+            <a:fontRef idx="minor">
+              <a:schemeClr val="tx1"/>
+            </a:fontRef>
+          </p:style>
+        </p:cxnSp>
+      </p:grpSp>
+      <p:sp>
+        <p:nvSpPr>
+          <p:cNvPr id="25" name="TextBox 24">
+            <a:extLst>
+              <a:ext uri="{FF2B5EF4-FFF2-40B4-BE49-F238E27FC236}">
+                <a16:creationId xmlns:a16="http://schemas.microsoft.com/office/drawing/2014/main" id="{ECC63EB7-8C93-D0E4-9883-BD353DBA142A}"/>
+              </a:ext>
+            </a:extLst>
+          </p:cNvPr>
+          <p:cNvSpPr txBox="1"/>
+          <p:nvPr/>
+        </p:nvSpPr>
+        <p:spPr>
+          <a:xfrm>
+            <a:off x="7800104" y="1847077"/>
+            <a:ext cx="2112424" cy="646331"/>
+          </a:xfrm>
+          <a:prstGeom prst="rect">
+            <a:avLst/>
+          </a:prstGeom>
+          <a:noFill/>
+        </p:spPr>
+        <p:txBody>
+          <a:bodyPr wrap="square" rtlCol="0">
+            <a:spAutoFit/>
+          </a:bodyPr>
+          <a:lstStyle/>
+          <a:p>
+            <a:pPr algn="ctr"/>
+            <a:r>
+              <a:rPr lang="en-GB" sz="3600" b="1" dirty="0"/>
+              <a:t>Pipeline</a:t>
+            </a:r>
+          </a:p>
+        </p:txBody>
+      </p:sp>
+    </p:spTree>
+    <p:extLst>
+      <p:ext uri="{BB962C8B-B14F-4D97-AF65-F5344CB8AC3E}">
+        <p14:creationId xmlns:p14="http://schemas.microsoft.com/office/powerpoint/2010/main" val="2180038919"/>
+      </p:ext>
+    </p:extLst>
+  </p:cSld>
+  <p:clrMapOvr>
+    <a:masterClrMapping/>
+  </p:clrMapOvr>
+</p:sld>
+</file>
+
+<file path=ppt/slides/slide9.xml><?xml version="1.0" encoding="utf-8"?>
 <p:sld xmlns:a="http://schemas.openxmlformats.org/drawingml/2006/main" xmlns:r="http://schemas.openxmlformats.org/officeDocument/2006/relationships" xmlns:p="http://schemas.openxmlformats.org/presentationml/2006/main">
   <p:cSld>
     <p:spTree>
@@ -7679,7 +9179,7 @@
           <p:cNvPr id="2" name="Titel 1">
             <a:extLst>
               <a:ext uri="{FF2B5EF4-FFF2-40B4-BE49-F238E27FC236}">
-                <a16:creationId xmlns:a16="http://schemas.microsoft.com/office/drawing/2014/main" id="{FA111BCC-1FCB-797D-6A46-449BCAB31DD4}"/>
+                <a16:creationId xmlns:a16="http://schemas.microsoft.com/office/drawing/2014/main" id="{DE91ACC9-79D4-17C2-681B-F78A70151FD9}"/>
               </a:ext>
             </a:extLst>
           </p:cNvPr>
@@ -7696,8 +9196,12 @@
           <a:lstStyle/>
           <a:p>
             <a:r>
+              <a:rPr lang="de-DE" dirty="0"/>
+              <a:t>System </a:t>
+            </a:r>
+            <a:r>
               <a:rPr lang="de-DE" dirty="0" err="1"/>
-              <a:t>Conclusion</a:t>
+              <a:t>Overview</a:t>
             </a:r>
             <a:endParaRPr lang="de-DE" dirty="0"/>
           </a:p>
@@ -7708,7 +9212,7 @@
           <p:cNvPr id="3" name="Inhaltsplatzhalter 2">
             <a:extLst>
               <a:ext uri="{FF2B5EF4-FFF2-40B4-BE49-F238E27FC236}">
-                <a16:creationId xmlns:a16="http://schemas.microsoft.com/office/drawing/2014/main" id="{13680EE8-07C5-28E5-EB00-12F747B70BC0}"/>
+                <a16:creationId xmlns:a16="http://schemas.microsoft.com/office/drawing/2014/main" id="{DAB83250-174B-4DC9-6B1F-0F086478514B}"/>
               </a:ext>
             </a:extLst>
           </p:cNvPr>
@@ -7725,76 +9229,37 @@
           <a:lstStyle/>
           <a:p>
             <a:r>
-              <a:rPr lang="de-DE" dirty="0" err="1"/>
-              <a:t>Successful</a:t>
-            </a:r>
-            <a:r>
-              <a:rPr lang="de-DE" dirty="0"/>
-              <a:t> </a:t>
-            </a:r>
-            <a:r>
-              <a:rPr lang="de-DE" dirty="0" err="1"/>
-              <a:t>proof</a:t>
-            </a:r>
-            <a:r>
-              <a:rPr lang="de-DE" dirty="0"/>
-              <a:t> </a:t>
-            </a:r>
-            <a:r>
-              <a:rPr lang="de-DE" dirty="0" err="1"/>
-              <a:t>of</a:t>
-            </a:r>
-            <a:r>
-              <a:rPr lang="de-DE" dirty="0"/>
-              <a:t> </a:t>
-            </a:r>
-            <a:r>
-              <a:rPr lang="de-DE" dirty="0" err="1"/>
-              <a:t>concept</a:t>
-            </a:r>
+              <a:rPr lang="en-US" dirty="0"/>
+              <a:t>Audio input </a:t>
+            </a:r>
+          </a:p>
+          <a:p>
+            <a:r>
+              <a:rPr lang="en-US" dirty="0"/>
+              <a:t>MFCC feature extraction </a:t>
+            </a:r>
+          </a:p>
+          <a:p>
+            <a:r>
+              <a:rPr lang="en-US" dirty="0"/>
+              <a:t>DNN + HMM processing </a:t>
+            </a:r>
+          </a:p>
+          <a:p>
+            <a:r>
+              <a:rPr lang="en-US" dirty="0"/>
+              <a:t>Word prediction</a:t>
+            </a:r>
+          </a:p>
+          <a:p>
             <a:endParaRPr lang="de-DE" dirty="0"/>
-          </a:p>
-          <a:p>
-            <a:r>
-              <a:rPr lang="de-DE" dirty="0"/>
-              <a:t>Speech </a:t>
-            </a:r>
-            <a:r>
-              <a:rPr lang="de-DE" dirty="0" err="1"/>
-              <a:t>as</a:t>
-            </a:r>
-            <a:r>
-              <a:rPr lang="de-DE" dirty="0"/>
-              <a:t> </a:t>
-            </a:r>
-            <a:r>
-              <a:rPr lang="de-DE" dirty="0" err="1"/>
-              <a:t>lightweight</a:t>
-            </a:r>
-            <a:r>
-              <a:rPr lang="de-DE" dirty="0"/>
-              <a:t> interface</a:t>
-            </a:r>
-            <a:endParaRPr lang="en-US" dirty="0"/>
-          </a:p>
-          <a:p>
-            <a:r>
-              <a:rPr lang="en-US" dirty="0"/>
-              <a:t>Real-time control works </a:t>
-            </a:r>
-          </a:p>
-          <a:p>
-            <a:r>
-              <a:rPr lang="en-US" dirty="0"/>
-              <a:t>Reliable command recognition </a:t>
-            </a:r>
           </a:p>
         </p:txBody>
       </p:sp>
     </p:spTree>
     <p:extLst>
       <p:ext uri="{BB962C8B-B14F-4D97-AF65-F5344CB8AC3E}">
-        <p14:creationId xmlns:p14="http://schemas.microsoft.com/office/powerpoint/2010/main" val="3625072128"/>
+        <p14:creationId xmlns:p14="http://schemas.microsoft.com/office/powerpoint/2010/main" val="466913703"/>
       </p:ext>
     </p:extLst>
   </p:cSld>

</xml_diff>